<commit_message>
docs: make Aramina model architecture editable
</commit_message>
<xml_diff>
--- a/docs/presentation/Aramina_Product_Overview_2026-07-27.pptx
+++ b/docs/presentation/Aramina_Product_Overview_2026-07-27.pptx
@@ -2,19 +2,19 @@
 <file path=ppt/presentation.xml><?xml version="1.0" encoding="utf-8"?>
 <p:presentation xmlns:p="http://schemas.openxmlformats.org/presentationml/2006/main">
   <p:sldMasterIdLst>
-    <p:sldMasterId xmlns:r="http://schemas.openxmlformats.org/officeDocument/2006/relationships" id="2147483648" r:id="Rb66699cb13874108"/>
+    <p:sldMasterId xmlns:r="http://schemas.openxmlformats.org/officeDocument/2006/relationships" id="2147483648" r:id="R9acf0f6d2fb34872"/>
   </p:sldMasterIdLst>
   <p:notesMasterIdLst>
-    <p:notesMasterId xmlns:r="http://schemas.openxmlformats.org/officeDocument/2006/relationships" r:id="R0340d23f8b70409e"/>
+    <p:notesMasterId xmlns:r="http://schemas.openxmlformats.org/officeDocument/2006/relationships" r:id="R94908dee10fc4145"/>
   </p:notesMasterIdLst>
   <p:sldIdLst>
-    <p:sldId xmlns:r="http://schemas.openxmlformats.org/officeDocument/2006/relationships" id="256" r:id="R4393676d1cf8418a"/>
-    <p:sldId xmlns:r="http://schemas.openxmlformats.org/officeDocument/2006/relationships" id="257" r:id="R5f869ffd90c946ad"/>
-    <p:sldId xmlns:r="http://schemas.openxmlformats.org/officeDocument/2006/relationships" id="258" r:id="R24ba31a501cf45b4"/>
-    <p:sldId xmlns:r="http://schemas.openxmlformats.org/officeDocument/2006/relationships" id="259" r:id="R080c6eda99ec408f"/>
-    <p:sldId xmlns:r="http://schemas.openxmlformats.org/officeDocument/2006/relationships" id="260" r:id="Rda0e9ac42b5d43c6"/>
-    <p:sldId xmlns:r="http://schemas.openxmlformats.org/officeDocument/2006/relationships" id="261" r:id="Rc4f6562058aa4323"/>
-    <p:sldId xmlns:r="http://schemas.openxmlformats.org/officeDocument/2006/relationships" id="262" r:id="Rfee08a818a21477d"/>
+    <p:sldId xmlns:r="http://schemas.openxmlformats.org/officeDocument/2006/relationships" id="256" r:id="Rd64f462315904c1c"/>
+    <p:sldId xmlns:r="http://schemas.openxmlformats.org/officeDocument/2006/relationships" id="257" r:id="R44723b5f579d4c42"/>
+    <p:sldId xmlns:r="http://schemas.openxmlformats.org/officeDocument/2006/relationships" id="258" r:id="R3fc5912a138c4dae"/>
+    <p:sldId xmlns:r="http://schemas.openxmlformats.org/officeDocument/2006/relationships" id="259" r:id="Raaae27333402417c"/>
+    <p:sldId xmlns:r="http://schemas.openxmlformats.org/officeDocument/2006/relationships" id="260" r:id="Rce9b4d4ccab149dd"/>
+    <p:sldId xmlns:r="http://schemas.openxmlformats.org/officeDocument/2006/relationships" id="261" r:id="Rc886273227154d88"/>
+    <p:sldId xmlns:r="http://schemas.openxmlformats.org/officeDocument/2006/relationships" id="262" r:id="Rdf1916c70c7b4a12"/>
   </p:sldIdLst>
   <p:sldSz cx="12192000" cy="6858000"/>
   <p:notesSz cx="6858000" cy="9144000"/>
@@ -1171,8 +1171,8 @@
   </p:cSld>
   <p:clrMap bg1="lt1" tx1="dk1" bg2="lt2" tx2="dk2" accent1="accent1" accent2="accent2" accent3="accent3" accent4="accent4" accent5="accent5" accent6="accent6" hlink="hlink" folHlink="folHlink"/>
   <p:sldLayoutIdLst>
-    <p:sldLayoutId xmlns:r="http://schemas.openxmlformats.org/officeDocument/2006/relationships" id="2147483649" r:id="Read7d83f1d7d4c34"/>
-    <p:sldLayoutId xmlns:r="http://schemas.openxmlformats.org/officeDocument/2006/relationships" id="2147483650" r:id="R8b3e128549614aa3"/>
+    <p:sldLayoutId xmlns:r="http://schemas.openxmlformats.org/officeDocument/2006/relationships" id="2147483649" r:id="Rd7eaa4f918f444a2"/>
+    <p:sldLayoutId xmlns:r="http://schemas.openxmlformats.org/officeDocument/2006/relationships" id="2147483650" r:id="R204eeeceb5814668"/>
   </p:sldLayoutIdLst>
   <p:txStyles>
     <p:titleStyle>
@@ -3620,7 +3620,7 @@
           <p:nvPr/>
         </p:nvPicPr>
         <p:blipFill>
-          <a:blip xmlns:r="http://schemas.openxmlformats.org/officeDocument/2006/relationships" xmlns:a="http://schemas.openxmlformats.org/drawingml/2006/main" r:embed="R6798f6eca4314881"/>
+          <a:blip xmlns:r="http://schemas.openxmlformats.org/officeDocument/2006/relationships" xmlns:a="http://schemas.openxmlformats.org/drawingml/2006/main" r:embed="R7e7ea9f714e84a81"/>
           <a:stretch xmlns:a="http://schemas.openxmlformats.org/drawingml/2006/main"/>
         </p:blipFill>
         <p:spPr>
@@ -5504,7 +5504,7 @@
       </p:sp>
       <p:cxnSp>
         <p:nvCxnSpPr>
-          <p:cNvPr id="65" name="Straight Arrow Connector 29"/>
+          <p:cNvPr id="87" name="Straight Arrow Connector 29"/>
           <p:cNvCxnSpPr>
             <a:stCxn xmlns:a="http://schemas.openxmlformats.org/drawingml/2006/main" id="3" idx="2"/>
             <a:endCxn xmlns:a="http://schemas.openxmlformats.org/drawingml/2006/main" id="4" idx="0"/>
@@ -5530,7 +5530,7 @@
       </p:cxnSp>
       <p:cxnSp>
         <p:nvCxnSpPr>
-          <p:cNvPr id="66" name="Straight Arrow Connector 30"/>
+          <p:cNvPr id="88" name="Straight Arrow Connector 30"/>
           <p:cNvCxnSpPr>
             <a:stCxn xmlns:a="http://schemas.openxmlformats.org/drawingml/2006/main" id="4" idx="2"/>
             <a:endCxn xmlns:a="http://schemas.openxmlformats.org/drawingml/2006/main" id="5" idx="0"/>
@@ -5556,7 +5556,7 @@
       </p:cxnSp>
       <p:cxnSp>
         <p:nvCxnSpPr>
-          <p:cNvPr id="67" name="Straight Arrow Connector 31"/>
+          <p:cNvPr id="89" name="Straight Arrow Connector 31"/>
           <p:cNvCxnSpPr>
             <a:stCxn xmlns:a="http://schemas.openxmlformats.org/drawingml/2006/main" id="5" idx="1"/>
             <a:endCxn xmlns:a="http://schemas.openxmlformats.org/drawingml/2006/main" id="6" idx="0"/>
@@ -5582,7 +5582,7 @@
       </p:cxnSp>
       <p:cxnSp>
         <p:nvCxnSpPr>
-          <p:cNvPr id="68" name="Straight Arrow Connector 32"/>
+          <p:cNvPr id="90" name="Straight Arrow Connector 32"/>
           <p:cNvCxnSpPr>
             <a:stCxn xmlns:a="http://schemas.openxmlformats.org/drawingml/2006/main" id="5" idx="2"/>
             <a:endCxn xmlns:a="http://schemas.openxmlformats.org/drawingml/2006/main" id="7" idx="0"/>
@@ -5608,7 +5608,7 @@
       </p:cxnSp>
       <p:cxnSp>
         <p:nvCxnSpPr>
-          <p:cNvPr id="69" name="Straight Arrow Connector 33"/>
+          <p:cNvPr id="91" name="Straight Arrow Connector 33"/>
           <p:cNvCxnSpPr>
             <a:stCxn xmlns:a="http://schemas.openxmlformats.org/drawingml/2006/main" id="7" idx="2"/>
             <a:endCxn xmlns:a="http://schemas.openxmlformats.org/drawingml/2006/main" id="8" idx="0"/>
@@ -5634,7 +5634,7 @@
       </p:cxnSp>
       <p:cxnSp>
         <p:nvCxnSpPr>
-          <p:cNvPr id="70" name="Straight Arrow Connector 34"/>
+          <p:cNvPr id="92" name="Straight Arrow Connector 34"/>
           <p:cNvCxnSpPr>
             <a:stCxn xmlns:a="http://schemas.openxmlformats.org/drawingml/2006/main" id="7" idx="3"/>
             <a:endCxn xmlns:a="http://schemas.openxmlformats.org/drawingml/2006/main" id="9" idx="1"/>
@@ -5660,7 +5660,7 @@
       </p:cxnSp>
       <p:cxnSp>
         <p:nvCxnSpPr>
-          <p:cNvPr id="71" name="Straight Arrow Connector 35"/>
+          <p:cNvPr id="93" name="Straight Arrow Connector 35"/>
           <p:cNvCxnSpPr>
             <a:stCxn xmlns:a="http://schemas.openxmlformats.org/drawingml/2006/main" id="9" idx="2"/>
             <a:endCxn xmlns:a="http://schemas.openxmlformats.org/drawingml/2006/main" id="10" idx="0"/>
@@ -5786,28 +5786,1220 @@
           </a:p>
         </p:txBody>
       </p:sp>
-      <p:pic>
-        <p:nvPicPr>
-          <p:cNvPr id="74" name=""/>
-          <p:cNvPicPr>
-            <a:picLocks xmlns:a="http://schemas.openxmlformats.org/drawingml/2006/main" noChangeAspect="1"/>
-          </p:cNvPicPr>
-          <p:nvPr/>
-        </p:nvPicPr>
-        <p:blipFill>
-          <a:blip xmlns:r="http://schemas.openxmlformats.org/officeDocument/2006/relationships" xmlns:a="http://schemas.openxmlformats.org/drawingml/2006/main" r:embed="Re2e509a69d4e4b92"/>
-          <a:stretch xmlns:a="http://schemas.openxmlformats.org/drawingml/2006/main"/>
-        </p:blipFill>
-        <p:spPr>
-          <a:xfrm xmlns:a="http://schemas.openxmlformats.org/drawingml/2006/main">
-            <a:off x="904875" y="1285875"/>
-            <a:ext cx="10382250" cy="5191125"/>
-          </a:xfrm>
-          <a:prstGeom xmlns:a="http://schemas.openxmlformats.org/drawingml/2006/main" prst="rect">
+      <p:sp>
+        <p:nvSpPr>
+          <p:cNvPr id="54" name="P1 profile">
+            <a:extLst xmlns:a="http://schemas.openxmlformats.org/drawingml/2006/main">
+              <a:ext uri="{FF2B5EF4-FFF2-40B4-BE49-F238E27FC236}">
+                <a16:creationId xmlns:a16="http://schemas.microsoft.com/office/drawing/2014/main" id="{53124C45-4284-4398-B5D4-56C6F93234BE}"/>
+              </a:ext>
+            </a:extLst>
+          </p:cNvPr>
+          <p:cNvSpPr>
+            <a:spLocks xmlns:a="http://schemas.openxmlformats.org/drawingml/2006/main" noGrp="1"/>
+          </p:cNvSpPr>
+          <p:nvPr/>
+        </p:nvSpPr>
+        <p:spPr>
+          <a:xfrm xmlns:a="http://schemas.openxmlformats.org/drawingml/2006/main">
+            <a:off x="428625" y="1714500"/>
+            <a:ext cx="1428750" cy="514350"/>
+          </a:xfrm>
+          <a:prstGeom xmlns:a="http://schemas.openxmlformats.org/drawingml/2006/main" prst="roundRect">
+            <a:avLst>
+              <a:gd name="adj" fmla="val 14815"/>
+            </a:avLst>
+          </a:prstGeom>
+          <a:solidFill xmlns:a="http://schemas.openxmlformats.org/drawingml/2006/main">
+            <a:srgbClr val="FFFFFF"/>
+          </a:solidFill>
+          <a:ln xmlns:a="http://schemas.openxmlformats.org/drawingml/2006/main" w="14288">
+            <a:solidFill>
+              <a:srgbClr val="CAD5E2"/>
+            </a:solidFill>
+            <a:prstDash val="solid"/>
+          </a:ln>
+        </p:spPr>
+        <p:txBody>
+          <a:bodyPr xmlns:a="http://schemas.openxmlformats.org/drawingml/2006/main"/>
+          <a:lstStyle xmlns:a="http://schemas.openxmlformats.org/drawingml/2006/main"/>
+          <a:p xmlns:a="http://schemas.openxmlformats.org/drawingml/2006/main">
+            <a:pPr algn="ctr">
+              <a:defRPr sz="1125">
+                <a:solidFill>
+                  <a:srgbClr val="000000"/>
+                </a:solidFill>
+              </a:defRPr>
+            </a:pPr>
+            <a:r>
+              <a:rPr sz="1125">
+                <a:solidFill>
+                  <a:srgbClr val="000000"/>
+                </a:solidFill>
+              </a:rPr>
+              <a:t>P1</a:t>
+            </a:r>
+          </a:p>
+          <a:p xmlns:a="http://schemas.openxmlformats.org/drawingml/2006/main">
+            <a:pPr algn="ctr">
+              <a:defRPr sz="1125">
+                <a:solidFill>
+                  <a:srgbClr val="000000"/>
+                </a:solidFill>
+              </a:defRPr>
+            </a:pPr>
+            <a:r>
+              <a:rPr sz="1125">
+                <a:solidFill>
+                  <a:srgbClr val="000000"/>
+                </a:solidFill>
+              </a:rPr>
+              <a:t>radial profile</a:t>
+            </a:r>
+          </a:p>
+        </p:txBody>
+      </p:sp>
+      <p:sp>
+        <p:nvSpPr>
+          <p:cNvPr id="55" name="P2 profile">
+            <a:extLst xmlns:a="http://schemas.openxmlformats.org/drawingml/2006/main">
+              <a:ext uri="{FF2B5EF4-FFF2-40B4-BE49-F238E27FC236}">
+                <a16:creationId xmlns:a16="http://schemas.microsoft.com/office/drawing/2014/main" id="{D6CFBB4D-0601-439B-9DCD-1E58D6902208}"/>
+              </a:ext>
+            </a:extLst>
+          </p:cNvPr>
+          <p:cNvSpPr>
+            <a:spLocks xmlns:a="http://schemas.openxmlformats.org/drawingml/2006/main" noGrp="1"/>
+          </p:cNvSpPr>
+          <p:nvPr/>
+        </p:nvSpPr>
+        <p:spPr>
+          <a:xfrm xmlns:a="http://schemas.openxmlformats.org/drawingml/2006/main">
+            <a:off x="428625" y="2476500"/>
+            <a:ext cx="1428750" cy="514350"/>
+          </a:xfrm>
+          <a:prstGeom xmlns:a="http://schemas.openxmlformats.org/drawingml/2006/main" prst="roundRect">
+            <a:avLst>
+              <a:gd name="adj" fmla="val 14815"/>
+            </a:avLst>
+          </a:prstGeom>
+          <a:solidFill xmlns:a="http://schemas.openxmlformats.org/drawingml/2006/main">
+            <a:srgbClr val="FFFFFF"/>
+          </a:solidFill>
+          <a:ln xmlns:a="http://schemas.openxmlformats.org/drawingml/2006/main" w="14288">
+            <a:solidFill>
+              <a:srgbClr val="CAD5E2"/>
+            </a:solidFill>
+            <a:prstDash val="solid"/>
+          </a:ln>
+        </p:spPr>
+        <p:txBody>
+          <a:bodyPr xmlns:a="http://schemas.openxmlformats.org/drawingml/2006/main"/>
+          <a:lstStyle xmlns:a="http://schemas.openxmlformats.org/drawingml/2006/main"/>
+          <a:p xmlns:a="http://schemas.openxmlformats.org/drawingml/2006/main">
+            <a:pPr algn="ctr">
+              <a:defRPr sz="1125">
+                <a:solidFill>
+                  <a:srgbClr val="000000"/>
+                </a:solidFill>
+              </a:defRPr>
+            </a:pPr>
+            <a:r>
+              <a:rPr sz="1125">
+                <a:solidFill>
+                  <a:srgbClr val="000000"/>
+                </a:solidFill>
+              </a:rPr>
+              <a:t>P2</a:t>
+            </a:r>
+          </a:p>
+          <a:p xmlns:a="http://schemas.openxmlformats.org/drawingml/2006/main">
+            <a:pPr algn="ctr">
+              <a:defRPr sz="1125">
+                <a:solidFill>
+                  <a:srgbClr val="000000"/>
+                </a:solidFill>
+              </a:defRPr>
+            </a:pPr>
+            <a:r>
+              <a:rPr sz="1125">
+                <a:solidFill>
+                  <a:srgbClr val="000000"/>
+                </a:solidFill>
+              </a:rPr>
+              <a:t>radial profile</a:t>
+            </a:r>
+          </a:p>
+        </p:txBody>
+      </p:sp>
+      <p:sp>
+        <p:nvSpPr>
+          <p:cNvPr id="56" name="P3 profile">
+            <a:extLst xmlns:a="http://schemas.openxmlformats.org/drawingml/2006/main">
+              <a:ext uri="{FF2B5EF4-FFF2-40B4-BE49-F238E27FC236}">
+                <a16:creationId xmlns:a16="http://schemas.microsoft.com/office/drawing/2014/main" id="{F3DEA6A2-0D8C-484C-A588-1BC66A30B5DA}"/>
+              </a:ext>
+            </a:extLst>
+          </p:cNvPr>
+          <p:cNvSpPr>
+            <a:spLocks xmlns:a="http://schemas.openxmlformats.org/drawingml/2006/main" noGrp="1"/>
+          </p:cNvSpPr>
+          <p:nvPr/>
+        </p:nvSpPr>
+        <p:spPr>
+          <a:xfrm xmlns:a="http://schemas.openxmlformats.org/drawingml/2006/main">
+            <a:off x="428625" y="3238500"/>
+            <a:ext cx="1428750" cy="514350"/>
+          </a:xfrm>
+          <a:prstGeom xmlns:a="http://schemas.openxmlformats.org/drawingml/2006/main" prst="roundRect">
+            <a:avLst>
+              <a:gd name="adj" fmla="val 14815"/>
+            </a:avLst>
+          </a:prstGeom>
+          <a:solidFill xmlns:a="http://schemas.openxmlformats.org/drawingml/2006/main">
+            <a:srgbClr val="FFFFFF"/>
+          </a:solidFill>
+          <a:ln xmlns:a="http://schemas.openxmlformats.org/drawingml/2006/main" w="14288">
+            <a:solidFill>
+              <a:srgbClr val="CAD5E2"/>
+            </a:solidFill>
+            <a:prstDash val="solid"/>
+          </a:ln>
+        </p:spPr>
+        <p:txBody>
+          <a:bodyPr xmlns:a="http://schemas.openxmlformats.org/drawingml/2006/main"/>
+          <a:lstStyle xmlns:a="http://schemas.openxmlformats.org/drawingml/2006/main"/>
+          <a:p xmlns:a="http://schemas.openxmlformats.org/drawingml/2006/main">
+            <a:pPr algn="ctr">
+              <a:defRPr sz="1125">
+                <a:solidFill>
+                  <a:srgbClr val="000000"/>
+                </a:solidFill>
+              </a:defRPr>
+            </a:pPr>
+            <a:r>
+              <a:rPr sz="1125">
+                <a:solidFill>
+                  <a:srgbClr val="000000"/>
+                </a:solidFill>
+              </a:rPr>
+              <a:t>P3</a:t>
+            </a:r>
+          </a:p>
+          <a:p xmlns:a="http://schemas.openxmlformats.org/drawingml/2006/main">
+            <a:pPr algn="ctr">
+              <a:defRPr sz="1125">
+                <a:solidFill>
+                  <a:srgbClr val="000000"/>
+                </a:solidFill>
+              </a:defRPr>
+            </a:pPr>
+            <a:r>
+              <a:rPr sz="1125">
+                <a:solidFill>
+                  <a:srgbClr val="000000"/>
+                </a:solidFill>
+              </a:rPr>
+              <a:t>radial profile</a:t>
+            </a:r>
+          </a:p>
+        </p:txBody>
+      </p:sp>
+      <p:sp>
+        <p:nvSpPr>
+          <p:cNvPr id="57" name="LR1 profile model">
+            <a:extLst xmlns:a="http://schemas.openxmlformats.org/drawingml/2006/main">
+              <a:ext uri="{FF2B5EF4-FFF2-40B4-BE49-F238E27FC236}">
+                <a16:creationId xmlns:a16="http://schemas.microsoft.com/office/drawing/2014/main" id="{FC6087C2-AF07-4211-A4C2-D1BEE86AAC4C}"/>
+              </a:ext>
+            </a:extLst>
+          </p:cNvPr>
+          <p:cNvSpPr>
+            <a:spLocks xmlns:a="http://schemas.openxmlformats.org/drawingml/2006/main" noGrp="1"/>
+          </p:cNvSpPr>
+          <p:nvPr/>
+        </p:nvSpPr>
+        <p:spPr>
+          <a:xfrm xmlns:a="http://schemas.openxmlformats.org/drawingml/2006/main">
+            <a:off x="2333625" y="2333625"/>
+            <a:ext cx="1381125" cy="819150"/>
+          </a:xfrm>
+          <a:prstGeom xmlns:a="http://schemas.openxmlformats.org/drawingml/2006/main" prst="roundRect">
+            <a:avLst>
+              <a:gd name="adj" fmla="val 9302"/>
+            </a:avLst>
+          </a:prstGeom>
+          <a:solidFill xmlns:a="http://schemas.openxmlformats.org/drawingml/2006/main">
+            <a:srgbClr val="EAF1F8"/>
+          </a:solidFill>
+          <a:ln xmlns:a="http://schemas.openxmlformats.org/drawingml/2006/main" w="14288">
+            <a:solidFill>
+              <a:srgbClr val="CAD5E2"/>
+            </a:solidFill>
+            <a:prstDash val="solid"/>
+          </a:ln>
+        </p:spPr>
+        <p:txBody>
+          <a:bodyPr xmlns:a="http://schemas.openxmlformats.org/drawingml/2006/main"/>
+          <a:lstStyle xmlns:a="http://schemas.openxmlformats.org/drawingml/2006/main"/>
+          <a:p xmlns:a="http://schemas.openxmlformats.org/drawingml/2006/main">
+            <a:pPr algn="ctr">
+              <a:defRPr sz="1350">
+                <a:solidFill>
+                  <a:srgbClr val="000000"/>
+                </a:solidFill>
+              </a:defRPr>
+            </a:pPr>
+            <a:r>
+              <a:rPr sz="1350">
+                <a:solidFill>
+                  <a:srgbClr val="000000"/>
+                </a:solidFill>
+              </a:rPr>
+              <a:t>LR1</a:t>
+            </a:r>
+          </a:p>
+          <a:p xmlns:a="http://schemas.openxmlformats.org/drawingml/2006/main">
+            <a:pPr algn="ctr">
+              <a:defRPr sz="1350">
+                <a:solidFill>
+                  <a:srgbClr val="000000"/>
+                </a:solidFill>
+              </a:defRPr>
+            </a:pPr>
+            <a:r>
+              <a:rPr sz="1350">
+                <a:solidFill>
+                  <a:srgbClr val="000000"/>
+                </a:solidFill>
+              </a:rPr>
+              <a:t>profile model</a:t>
+            </a:r>
+          </a:p>
+        </p:txBody>
+      </p:sp>
+      <p:sp>
+        <p:nvSpPr>
+          <p:cNvPr id="58" name="Measurement p target">
+            <a:extLst xmlns:a="http://schemas.openxmlformats.org/drawingml/2006/main">
+              <a:ext uri="{FF2B5EF4-FFF2-40B4-BE49-F238E27FC236}">
+                <a16:creationId xmlns:a16="http://schemas.microsoft.com/office/drawing/2014/main" id="{F9C68B05-F0CE-49AC-95DF-C344C4DFC38C}"/>
+              </a:ext>
+            </a:extLst>
+          </p:cNvPr>
+          <p:cNvSpPr>
+            <a:spLocks xmlns:a="http://schemas.openxmlformats.org/drawingml/2006/main" noGrp="1"/>
+          </p:cNvSpPr>
+          <p:nvPr/>
+        </p:nvSpPr>
+        <p:spPr>
+          <a:xfrm xmlns:a="http://schemas.openxmlformats.org/drawingml/2006/main">
+            <a:off x="4191000" y="2238375"/>
+            <a:ext cx="1285875" cy="1009650"/>
+          </a:xfrm>
+          <a:prstGeom xmlns:a="http://schemas.openxmlformats.org/drawingml/2006/main" prst="roundRect">
+            <a:avLst>
+              <a:gd name="adj" fmla="val 7547"/>
+            </a:avLst>
+          </a:prstGeom>
+          <a:solidFill xmlns:a="http://schemas.openxmlformats.org/drawingml/2006/main">
+            <a:srgbClr val="F5F8FC"/>
+          </a:solidFill>
+          <a:ln xmlns:a="http://schemas.openxmlformats.org/drawingml/2006/main" w="14288">
+            <a:solidFill>
+              <a:srgbClr val="CAD5E2"/>
+            </a:solidFill>
+            <a:prstDash val="solid"/>
+          </a:ln>
+        </p:spPr>
+        <p:txBody>
+          <a:bodyPr xmlns:a="http://schemas.openxmlformats.org/drawingml/2006/main"/>
+          <a:lstStyle xmlns:a="http://schemas.openxmlformats.org/drawingml/2006/main"/>
+          <a:p xmlns:a="http://schemas.openxmlformats.org/drawingml/2006/main">
+            <a:pPr algn="ctr">
+              <a:defRPr sz="1125">
+                <a:solidFill>
+                  <a:srgbClr val="000000"/>
+                </a:solidFill>
+              </a:defRPr>
+            </a:pPr>
+            <a:r>
+              <a:rPr sz="1125">
+                <a:solidFill>
+                  <a:srgbClr val="000000"/>
+                </a:solidFill>
+              </a:rPr>
+              <a:t>p_target 1</a:t>
+            </a:r>
+          </a:p>
+          <a:p xmlns:a="http://schemas.openxmlformats.org/drawingml/2006/main">
+            <a:pPr algn="ctr">
+              <a:defRPr sz="1125">
+                <a:solidFill>
+                  <a:srgbClr val="000000"/>
+                </a:solidFill>
+              </a:defRPr>
+            </a:pPr>
+            <a:r>
+              <a:rPr sz="1125">
+                <a:solidFill>
+                  <a:srgbClr val="000000"/>
+                </a:solidFill>
+              </a:rPr>
+              <a:t>p_target 2</a:t>
+            </a:r>
+          </a:p>
+          <a:p xmlns:a="http://schemas.openxmlformats.org/drawingml/2006/main">
+            <a:pPr algn="ctr">
+              <a:defRPr sz="1125">
+                <a:solidFill>
+                  <a:srgbClr val="000000"/>
+                </a:solidFill>
+              </a:defRPr>
+            </a:pPr>
+            <a:r>
+              <a:rPr sz="1125">
+                <a:solidFill>
+                  <a:srgbClr val="000000"/>
+                </a:solidFill>
+              </a:rPr>
+              <a:t>p_target 3</a:t>
+            </a:r>
+          </a:p>
+        </p:txBody>
+      </p:sp>
+      <p:sp>
+        <p:nvSpPr>
+          <p:cNvPr id="59" name="Target p target aggregate">
+            <a:extLst xmlns:a="http://schemas.openxmlformats.org/drawingml/2006/main">
+              <a:ext uri="{FF2B5EF4-FFF2-40B4-BE49-F238E27FC236}">
+                <a16:creationId xmlns:a16="http://schemas.microsoft.com/office/drawing/2014/main" id="{294954D9-5CDC-4D55-8773-8AF5CC75A577}"/>
+              </a:ext>
+            </a:extLst>
+          </p:cNvPr>
+          <p:cNvSpPr>
+            <a:spLocks xmlns:a="http://schemas.openxmlformats.org/drawingml/2006/main" noGrp="1"/>
+          </p:cNvSpPr>
+          <p:nvPr/>
+        </p:nvSpPr>
+        <p:spPr>
+          <a:xfrm xmlns:a="http://schemas.openxmlformats.org/drawingml/2006/main">
+            <a:off x="5953125" y="2333625"/>
+            <a:ext cx="1571625" cy="819150"/>
+          </a:xfrm>
+          <a:prstGeom xmlns:a="http://schemas.openxmlformats.org/drawingml/2006/main" prst="roundRect">
+            <a:avLst>
+              <a:gd name="adj" fmla="val 9302"/>
+            </a:avLst>
+          </a:prstGeom>
+          <a:solidFill xmlns:a="http://schemas.openxmlformats.org/drawingml/2006/main">
+            <a:srgbClr val="EAF1F8"/>
+          </a:solidFill>
+          <a:ln xmlns:a="http://schemas.openxmlformats.org/drawingml/2006/main" w="14288">
+            <a:solidFill>
+              <a:srgbClr val="CAD5E2"/>
+            </a:solidFill>
+            <a:prstDash val="solid"/>
+          </a:ln>
+        </p:spPr>
+        <p:txBody>
+          <a:bodyPr xmlns:a="http://schemas.openxmlformats.org/drawingml/2006/main"/>
+          <a:lstStyle xmlns:a="http://schemas.openxmlformats.org/drawingml/2006/main"/>
+          <a:p xmlns:a="http://schemas.openxmlformats.org/drawingml/2006/main">
+            <a:pPr algn="ctr">
+              <a:defRPr sz="1275">
+                <a:solidFill>
+                  <a:srgbClr val="000000"/>
+                </a:solidFill>
+              </a:defRPr>
+            </a:pPr>
+            <a:r>
+              <a:rPr sz="1275">
+                <a:solidFill>
+                  <a:srgbClr val="000000"/>
+                </a:solidFill>
+              </a:rPr>
+              <a:t>target p_target</a:t>
+            </a:r>
+          </a:p>
+          <a:p xmlns:a="http://schemas.openxmlformats.org/drawingml/2006/main">
+            <a:pPr algn="ctr">
+              <a:defRPr sz="1275">
+                <a:solidFill>
+                  <a:srgbClr val="000000"/>
+                </a:solidFill>
+              </a:defRPr>
+            </a:pPr>
+            <a:r>
+              <a:rPr sz="1275">
+                <a:solidFill>
+                  <a:srgbClr val="000000"/>
+                </a:solidFill>
+              </a:rPr>
+              <a:t>logit average</a:t>
+            </a:r>
+          </a:p>
+        </p:txBody>
+      </p:sp>
+      <p:sp>
+        <p:nvSpPr>
+          <p:cNvPr id="60" name="Symmetry availability gate">
+            <a:extLst xmlns:a="http://schemas.openxmlformats.org/drawingml/2006/main">
+              <a:ext uri="{FF2B5EF4-FFF2-40B4-BE49-F238E27FC236}">
+                <a16:creationId xmlns:a16="http://schemas.microsoft.com/office/drawing/2014/main" id="{89E36C25-83C7-42BE-9E41-395FDCC8D2EC}"/>
+              </a:ext>
+            </a:extLst>
+          </p:cNvPr>
+          <p:cNvSpPr>
+            <a:spLocks xmlns:a="http://schemas.openxmlformats.org/drawingml/2006/main" noGrp="1"/>
+          </p:cNvSpPr>
+          <p:nvPr/>
+        </p:nvSpPr>
+        <p:spPr>
+          <a:xfrm xmlns:a="http://schemas.openxmlformats.org/drawingml/2006/main">
+            <a:off x="5953125" y="3667125"/>
+            <a:ext cx="1809750" cy="609600"/>
+          </a:xfrm>
+          <a:prstGeom xmlns:a="http://schemas.openxmlformats.org/drawingml/2006/main" prst="roundRect">
+            <a:avLst>
+              <a:gd name="adj" fmla="val 12500"/>
+            </a:avLst>
+          </a:prstGeom>
+          <a:solidFill xmlns:a="http://schemas.openxmlformats.org/drawingml/2006/main">
+            <a:srgbClr val="FFF6E5"/>
+          </a:solidFill>
+          <a:ln xmlns:a="http://schemas.openxmlformats.org/drawingml/2006/main" w="14288">
+            <a:solidFill>
+              <a:srgbClr val="CAD5E2"/>
+            </a:solidFill>
+            <a:prstDash val="solid"/>
+          </a:ln>
+        </p:spPr>
+        <p:txBody>
+          <a:bodyPr xmlns:a="http://schemas.openxmlformats.org/drawingml/2006/main"/>
+          <a:lstStyle xmlns:a="http://schemas.openxmlformats.org/drawingml/2006/main"/>
+          <a:p xmlns:a="http://schemas.openxmlformats.org/drawingml/2006/main">
+            <a:pPr algn="ctr">
+              <a:defRPr sz="1050">
+                <a:solidFill>
+                  <a:srgbClr val="000000"/>
+                </a:solidFill>
+              </a:defRPr>
+            </a:pPr>
+            <a:r>
+              <a:rPr sz="1050">
+                <a:solidFill>
+                  <a:srgbClr val="000000"/>
+                </a:solidFill>
+              </a:rPr>
+              <a:t>Both breasts have</a:t>
+            </a:r>
+          </a:p>
+          <a:p xmlns:a="http://schemas.openxmlformats.org/drawingml/2006/main">
+            <a:pPr algn="ctr">
+              <a:defRPr sz="1050">
+                <a:solidFill>
+                  <a:srgbClr val="000000"/>
+                </a:solidFill>
+              </a:defRPr>
+            </a:pPr>
+            <a:r>
+              <a:rPr sz="1050">
+                <a:solidFill>
+                  <a:srgbClr val="000000"/>
+                </a:solidFill>
+              </a:rPr>
+              <a:t>&gt;=2 valid measurements?</a:t>
+            </a:r>
+          </a:p>
+        </p:txBody>
+      </p:sp>
+      <p:sp>
+        <p:nvSpPr>
+          <p:cNvPr id="61" name="Symmetry input to LR2">
+            <a:extLst xmlns:a="http://schemas.openxmlformats.org/drawingml/2006/main">
+              <a:ext uri="{FF2B5EF4-FFF2-40B4-BE49-F238E27FC236}">
+                <a16:creationId xmlns:a16="http://schemas.microsoft.com/office/drawing/2014/main" id="{9191F082-3FD3-4904-9D48-A4B063A7AFE3}"/>
+              </a:ext>
+            </a:extLst>
+          </p:cNvPr>
+          <p:cNvSpPr>
+            <a:spLocks xmlns:a="http://schemas.openxmlformats.org/drawingml/2006/main" noGrp="1"/>
+          </p:cNvSpPr>
+          <p:nvPr/>
+        </p:nvSpPr>
+        <p:spPr>
+          <a:xfrm xmlns:a="http://schemas.openxmlformats.org/drawingml/2006/main">
+            <a:off x="8143875" y="3667125"/>
+            <a:ext cx="2381250" cy="876300"/>
+          </a:xfrm>
+          <a:prstGeom xmlns:a="http://schemas.openxmlformats.org/drawingml/2006/main" prst="roundRect">
+            <a:avLst>
+              <a:gd name="adj" fmla="val 8696"/>
+            </a:avLst>
+          </a:prstGeom>
+          <a:solidFill xmlns:a="http://schemas.openxmlformats.org/drawingml/2006/main">
+            <a:srgbClr val="FFF6E5"/>
+          </a:solidFill>
+          <a:ln xmlns:a="http://schemas.openxmlformats.org/drawingml/2006/main" w="14288">
+            <a:solidFill>
+              <a:srgbClr val="CAD5E2"/>
+            </a:solidFill>
+            <a:prstDash val="solid"/>
+          </a:ln>
+        </p:spPr>
+        <p:txBody>
+          <a:bodyPr xmlns:a="http://schemas.openxmlformats.org/drawingml/2006/main"/>
+          <a:lstStyle xmlns:a="http://schemas.openxmlformats.org/drawingml/2006/main"/>
+          <a:p xmlns:a="http://schemas.openxmlformats.org/drawingml/2006/main">
+            <a:pPr algn="ctr">
+              <a:defRPr sz="900">
+                <a:solidFill>
+                  <a:srgbClr val="000000"/>
+                </a:solidFill>
+              </a:defRPr>
+            </a:pPr>
+            <a:r>
+              <a:rPr sz="900">
+                <a:solidFill>
+                  <a:srgbClr val="000000"/>
+                </a:solidFill>
+              </a:rPr>
+              <a:t>Symmetry input to LR2</a:t>
+            </a:r>
+          </a:p>
+          <a:p xmlns:a="http://schemas.openxmlformats.org/drawingml/2006/main">
+            <a:pPr algn="ctr">
+              <a:defRPr sz="900">
+                <a:solidFill>
+                  <a:srgbClr val="000000"/>
+                </a:solidFill>
+              </a:defRPr>
+            </a:pPr>
+            <a:r>
+              <a:rPr sz="900">
+                <a:solidFill>
+                  <a:srgbClr val="000000"/>
+                </a:solidFill>
+              </a:rPr>
+              <a:t>Yes: SK Core 4 (Wasserstein, RMS1, RMS2, peak delta)</a:t>
+            </a:r>
+          </a:p>
+          <a:p xmlns:a="http://schemas.openxmlformats.org/drawingml/2006/main">
+            <a:pPr algn="ctr">
+              <a:defRPr sz="900">
+                <a:solidFill>
+                  <a:srgbClr val="000000"/>
+                </a:solidFill>
+              </a:defRPr>
+            </a:pPr>
+            <a:r>
+              <a:rPr sz="900">
+                <a:solidFill>
+                  <a:srgbClr val="000000"/>
+                </a:solidFill>
+              </a:rPr>
+              <a:t>No: zero vector; reliability: low</a:t>
+            </a:r>
+          </a:p>
+        </p:txBody>
+      </p:sp>
+      <p:sp>
+        <p:nvSpPr>
+          <p:cNvPr id="62" name="LR2 refinement">
+            <a:extLst xmlns:a="http://schemas.openxmlformats.org/drawingml/2006/main">
+              <a:ext uri="{FF2B5EF4-FFF2-40B4-BE49-F238E27FC236}">
+                <a16:creationId xmlns:a16="http://schemas.microsoft.com/office/drawing/2014/main" id="{D1D46F84-59A7-4B6C-9F1B-A21BE87430EB}"/>
+              </a:ext>
+            </a:extLst>
+          </p:cNvPr>
+          <p:cNvSpPr>
+            <a:spLocks xmlns:a="http://schemas.openxmlformats.org/drawingml/2006/main" noGrp="1"/>
+          </p:cNvSpPr>
+          <p:nvPr/>
+        </p:nvSpPr>
+        <p:spPr>
+          <a:xfrm xmlns:a="http://schemas.openxmlformats.org/drawingml/2006/main">
+            <a:off x="8620125" y="2047875"/>
+            <a:ext cx="1857375" cy="914400"/>
+          </a:xfrm>
+          <a:prstGeom xmlns:a="http://schemas.openxmlformats.org/drawingml/2006/main" prst="roundRect">
+            <a:avLst>
+              <a:gd name="adj" fmla="val 8333"/>
+            </a:avLst>
+          </a:prstGeom>
+          <a:solidFill xmlns:a="http://schemas.openxmlformats.org/drawingml/2006/main">
+            <a:srgbClr val="DDEBF7"/>
+          </a:solidFill>
+          <a:ln xmlns:a="http://schemas.openxmlformats.org/drawingml/2006/main" w="14288">
+            <a:solidFill>
+              <a:srgbClr val="CAD5E2"/>
+            </a:solidFill>
+            <a:prstDash val="solid"/>
+          </a:ln>
+        </p:spPr>
+        <p:txBody>
+          <a:bodyPr xmlns:a="http://schemas.openxmlformats.org/drawingml/2006/main"/>
+          <a:lstStyle xmlns:a="http://schemas.openxmlformats.org/drawingml/2006/main"/>
+          <a:p xmlns:a="http://schemas.openxmlformats.org/drawingml/2006/main">
+            <a:pPr algn="ctr">
+              <a:defRPr sz="1200">
+                <a:solidFill>
+                  <a:srgbClr val="000000"/>
+                </a:solidFill>
+              </a:defRPr>
+            </a:pPr>
+            <a:r>
+              <a:rPr sz="1200">
+                <a:solidFill>
+                  <a:srgbClr val="000000"/>
+                </a:solidFill>
+              </a:rPr>
+              <a:t>LR2 refinement</a:t>
+            </a:r>
+          </a:p>
+          <a:p xmlns:a="http://schemas.openxmlformats.org/drawingml/2006/main">
+            <a:pPr algn="ctr">
+              <a:defRPr sz="1200">
+                <a:solidFill>
+                  <a:srgbClr val="000000"/>
+                </a:solidFill>
+              </a:defRPr>
+            </a:pPr>
+            <a:r>
+              <a:rPr sz="1200">
+                <a:solidFill>
+                  <a:srgbClr val="000000"/>
+                </a:solidFill>
+              </a:rPr>
+              <a:t>target p_target + age</a:t>
+            </a:r>
+          </a:p>
+          <a:p xmlns:a="http://schemas.openxmlformats.org/drawingml/2006/main">
+            <a:pPr algn="ctr">
+              <a:defRPr sz="1200">
+                <a:solidFill>
+                  <a:srgbClr val="000000"/>
+                </a:solidFill>
+              </a:defRPr>
+            </a:pPr>
+            <a:r>
+              <a:rPr sz="1200">
+                <a:solidFill>
+                  <a:srgbClr val="000000"/>
+                </a:solidFill>
+              </a:rPr>
+              <a:t>+ symmetry / zeros</a:t>
+            </a:r>
+          </a:p>
+        </p:txBody>
+      </p:sp>
+      <p:sp>
+        <p:nvSpPr>
+          <p:cNvPr id="63" name="Final p cancer">
+            <a:extLst xmlns:a="http://schemas.openxmlformats.org/drawingml/2006/main">
+              <a:ext uri="{FF2B5EF4-FFF2-40B4-BE49-F238E27FC236}">
+                <a16:creationId xmlns:a16="http://schemas.microsoft.com/office/drawing/2014/main" id="{1CCFD13E-1E77-463B-92F6-FA2072DD3326}"/>
+              </a:ext>
+            </a:extLst>
+          </p:cNvPr>
+          <p:cNvSpPr>
+            <a:spLocks xmlns:a="http://schemas.openxmlformats.org/drawingml/2006/main" noGrp="1"/>
+          </p:cNvSpPr>
+          <p:nvPr/>
+        </p:nvSpPr>
+        <p:spPr>
+          <a:xfrm xmlns:a="http://schemas.openxmlformats.org/drawingml/2006/main">
+            <a:off x="10810875" y="2333625"/>
+            <a:ext cx="1095375" cy="552450"/>
+          </a:xfrm>
+          <a:prstGeom xmlns:a="http://schemas.openxmlformats.org/drawingml/2006/main" prst="roundRect">
+            <a:avLst>
+              <a:gd name="adj" fmla="val 13793"/>
+            </a:avLst>
+          </a:prstGeom>
+          <a:solidFill xmlns:a="http://schemas.openxmlformats.org/drawingml/2006/main">
+            <a:srgbClr val="E1F1E5"/>
+          </a:solidFill>
+          <a:ln xmlns:a="http://schemas.openxmlformats.org/drawingml/2006/main" w="14288">
+            <a:solidFill>
+              <a:srgbClr val="CAD5E2"/>
+            </a:solidFill>
+            <a:prstDash val="solid"/>
+          </a:ln>
+        </p:spPr>
+        <p:txBody>
+          <a:bodyPr xmlns:a="http://schemas.openxmlformats.org/drawingml/2006/main"/>
+          <a:lstStyle xmlns:a="http://schemas.openxmlformats.org/drawingml/2006/main"/>
+          <a:p xmlns:a="http://schemas.openxmlformats.org/drawingml/2006/main">
+            <a:pPr algn="ctr">
+              <a:defRPr sz="1275">
+                <a:solidFill>
+                  <a:srgbClr val="000000"/>
+                </a:solidFill>
+              </a:defRPr>
+            </a:pPr>
+            <a:r>
+              <a:rPr sz="1275">
+                <a:solidFill>
+                  <a:srgbClr val="000000"/>
+                </a:solidFill>
+              </a:rPr>
+              <a:t>Final p_cancer</a:t>
+            </a:r>
+          </a:p>
+        </p:txBody>
+      </p:sp>
+      <p:sp>
+        <p:nvSpPr>
+          <p:cNvPr id="64" name="Fixed threshold">
+            <a:extLst xmlns:a="http://schemas.openxmlformats.org/drawingml/2006/main">
+              <a:ext uri="{FF2B5EF4-FFF2-40B4-BE49-F238E27FC236}">
+                <a16:creationId xmlns:a16="http://schemas.microsoft.com/office/drawing/2014/main" id="{D6B1C326-BC04-462C-B005-FF8A61C8FA45}"/>
+              </a:ext>
+            </a:extLst>
+          </p:cNvPr>
+          <p:cNvSpPr>
+            <a:spLocks xmlns:a="http://schemas.openxmlformats.org/drawingml/2006/main" noGrp="1"/>
+          </p:cNvSpPr>
+          <p:nvPr/>
+        </p:nvSpPr>
+        <p:spPr>
+          <a:xfrm xmlns:a="http://schemas.openxmlformats.org/drawingml/2006/main">
+            <a:off x="10810875" y="3333750"/>
+            <a:ext cx="1095375" cy="552450"/>
+          </a:xfrm>
+          <a:prstGeom xmlns:a="http://schemas.openxmlformats.org/drawingml/2006/main" prst="roundRect">
+            <a:avLst>
+              <a:gd name="adj" fmla="val 13793"/>
+            </a:avLst>
+          </a:prstGeom>
+          <a:solidFill xmlns:a="http://schemas.openxmlformats.org/drawingml/2006/main">
+            <a:srgbClr val="E1F1E5"/>
+          </a:solidFill>
+          <a:ln xmlns:a="http://schemas.openxmlformats.org/drawingml/2006/main" w="14288">
+            <a:solidFill>
+              <a:srgbClr val="CAD5E2"/>
+            </a:solidFill>
+            <a:prstDash val="solid"/>
+          </a:ln>
+        </p:spPr>
+        <p:txBody>
+          <a:bodyPr xmlns:a="http://schemas.openxmlformats.org/drawingml/2006/main"/>
+          <a:lstStyle xmlns:a="http://schemas.openxmlformats.org/drawingml/2006/main"/>
+          <a:p xmlns:a="http://schemas.openxmlformats.org/drawingml/2006/main">
+            <a:pPr algn="ctr">
+              <a:defRPr sz="1050">
+                <a:solidFill>
+                  <a:srgbClr val="000000"/>
+                </a:solidFill>
+              </a:defRPr>
+            </a:pPr>
+            <a:r>
+              <a:rPr sz="1050">
+                <a:solidFill>
+                  <a:srgbClr val="000000"/>
+                </a:solidFill>
+              </a:rPr>
+              <a:t>Fixed threshold</a:t>
+            </a:r>
+          </a:p>
+          <a:p xmlns:a="http://schemas.openxmlformats.org/drawingml/2006/main">
+            <a:pPr algn="ctr">
+              <a:defRPr sz="1050">
+                <a:solidFill>
+                  <a:srgbClr val="000000"/>
+                </a:solidFill>
+              </a:defRPr>
+            </a:pPr>
+            <a:r>
+              <a:rPr sz="1050">
+                <a:solidFill>
+                  <a:srgbClr val="000000"/>
+                </a:solidFill>
+              </a:rPr>
+              <a:t>0.24666</a:t>
+            </a:r>
+          </a:p>
+        </p:txBody>
+      </p:sp>
+      <p:sp>
+        <p:nvSpPr>
+          <p:cNvPr id="65" name="Biopsy action">
+            <a:extLst xmlns:a="http://schemas.openxmlformats.org/drawingml/2006/main">
+              <a:ext uri="{FF2B5EF4-FFF2-40B4-BE49-F238E27FC236}">
+                <a16:creationId xmlns:a16="http://schemas.microsoft.com/office/drawing/2014/main" id="{1DBCDF89-7735-4560-9624-CA79194C0D3E}"/>
+              </a:ext>
+            </a:extLst>
+          </p:cNvPr>
+          <p:cNvSpPr>
+            <a:spLocks xmlns:a="http://schemas.openxmlformats.org/drawingml/2006/main" noGrp="1"/>
+          </p:cNvSpPr>
+          <p:nvPr/>
+        </p:nvSpPr>
+        <p:spPr>
+          <a:xfrm xmlns:a="http://schemas.openxmlformats.org/drawingml/2006/main">
+            <a:off x="10477500" y="4381500"/>
+            <a:ext cx="1428750" cy="628650"/>
+          </a:xfrm>
+          <a:prstGeom xmlns:a="http://schemas.openxmlformats.org/drawingml/2006/main" prst="roundRect">
+            <a:avLst>
+              <a:gd name="adj" fmla="val 12121"/>
+            </a:avLst>
+          </a:prstGeom>
+          <a:solidFill xmlns:a="http://schemas.openxmlformats.org/drawingml/2006/main">
+            <a:srgbClr val="E1F1E5"/>
+          </a:solidFill>
+          <a:ln xmlns:a="http://schemas.openxmlformats.org/drawingml/2006/main" w="14288">
+            <a:solidFill>
+              <a:srgbClr val="CAD5E2"/>
+            </a:solidFill>
+            <a:prstDash val="solid"/>
+          </a:ln>
+        </p:spPr>
+        <p:txBody>
+          <a:bodyPr xmlns:a="http://schemas.openxmlformats.org/drawingml/2006/main"/>
+          <a:lstStyle xmlns:a="http://schemas.openxmlformats.org/drawingml/2006/main"/>
+          <a:p xmlns:a="http://schemas.openxmlformats.org/drawingml/2006/main">
+            <a:pPr algn="ctr">
+              <a:defRPr sz="1050">
+                <a:solidFill>
+                  <a:srgbClr val="000000"/>
+                </a:solidFill>
+              </a:defRPr>
+            </a:pPr>
+            <a:r>
+              <a:rPr sz="1050">
+                <a:solidFill>
+                  <a:srgbClr val="000000"/>
+                </a:solidFill>
+              </a:rPr>
+              <a:t>Biopsy action</a:t>
+            </a:r>
+          </a:p>
+          <a:p xmlns:a="http://schemas.openxmlformats.org/drawingml/2006/main">
+            <a:pPr algn="ctr">
+              <a:defRPr sz="1050">
+                <a:solidFill>
+                  <a:srgbClr val="000000"/>
+                </a:solidFill>
+              </a:defRPr>
+            </a:pPr>
+            <a:r>
+              <a:rPr sz="1050">
+                <a:solidFill>
+                  <a:srgbClr val="000000"/>
+                </a:solidFill>
+              </a:rPr>
+              <a:t>required / not required</a:t>
+            </a:r>
+          </a:p>
+        </p:txBody>
+      </p:sp>
+      <p:cxnSp>
+        <p:nvCxnSpPr>
+          <p:cNvPr id="108" name=""/>
+          <p:cNvCxnSpPr>
+            <a:stCxn xmlns:a="http://schemas.openxmlformats.org/drawingml/2006/main" id="54" idx="3"/>
+            <a:endCxn xmlns:a="http://schemas.openxmlformats.org/drawingml/2006/main" id="57" idx="1"/>
+          </p:cNvCxnSpPr>
+          <p:nvPr/>
+        </p:nvCxnSpPr>
+        <p:spPr>
+          <a:xfrm xmlns:a="http://schemas.openxmlformats.org/drawingml/2006/main">
+            <a:off x="1857375" y="1971675"/>
+            <a:ext cx="476250" cy="771525"/>
+          </a:xfrm>
+          <a:prstGeom xmlns:a="http://schemas.openxmlformats.org/drawingml/2006/main" prst="bentConnector3">
+            <a:avLst>
+              <a:gd name="adj1" fmla="val 50000"/>
+            </a:avLst>
+          </a:prstGeom>
+          <a:ln xmlns:a="http://schemas.openxmlformats.org/drawingml/2006/main" w="19050">
+            <a:solidFill>
+              <a:srgbClr val="45556C"/>
+            </a:solidFill>
+            <a:prstDash val="solid"/>
+            <a:tailEnd type="arrow" w="med" len="med"/>
+          </a:ln>
+        </p:spPr>
+      </p:cxnSp>
+      <p:cxnSp>
+        <p:nvCxnSpPr>
+          <p:cNvPr id="109" name=""/>
+          <p:cNvCxnSpPr>
+            <a:stCxn xmlns:a="http://schemas.openxmlformats.org/drawingml/2006/main" id="55" idx="3"/>
+            <a:endCxn xmlns:a="http://schemas.openxmlformats.org/drawingml/2006/main" id="57" idx="1"/>
+          </p:cNvCxnSpPr>
+          <p:nvPr/>
+        </p:nvCxnSpPr>
+        <p:spPr>
+          <a:xfrm xmlns:a="http://schemas.openxmlformats.org/drawingml/2006/main">
+            <a:off x="1857375" y="2733675"/>
+            <a:ext cx="476250" cy="9525"/>
+          </a:xfrm>
+          <a:prstGeom xmlns:a="http://schemas.openxmlformats.org/drawingml/2006/main" prst="bentConnector3">
+            <a:avLst>
+              <a:gd name="adj1" fmla="val 50000"/>
+            </a:avLst>
+          </a:prstGeom>
+          <a:ln xmlns:a="http://schemas.openxmlformats.org/drawingml/2006/main" w="19050">
+            <a:solidFill>
+              <a:srgbClr val="45556C"/>
+            </a:solidFill>
+            <a:prstDash val="solid"/>
+            <a:tailEnd type="arrow" w="med" len="med"/>
+          </a:ln>
+        </p:spPr>
+      </p:cxnSp>
+      <p:cxnSp>
+        <p:nvCxnSpPr>
+          <p:cNvPr id="110" name=""/>
+          <p:cNvCxnSpPr>
+            <a:stCxn xmlns:a="http://schemas.openxmlformats.org/drawingml/2006/main" id="56" idx="3"/>
+            <a:endCxn xmlns:a="http://schemas.openxmlformats.org/drawingml/2006/main" id="57" idx="1"/>
+          </p:cNvCxnSpPr>
+          <p:nvPr/>
+        </p:nvCxnSpPr>
+        <p:spPr>
+          <a:xfrm xmlns:a="http://schemas.openxmlformats.org/drawingml/2006/main" flipV="1">
+            <a:off x="1857375" y="2743200"/>
+            <a:ext cx="476250" cy="752475"/>
+          </a:xfrm>
+          <a:prstGeom xmlns:a="http://schemas.openxmlformats.org/drawingml/2006/main" prst="bentConnector3">
+            <a:avLst>
+              <a:gd name="adj1" fmla="val 50000"/>
+            </a:avLst>
+          </a:prstGeom>
+          <a:ln xmlns:a="http://schemas.openxmlformats.org/drawingml/2006/main" w="19050">
+            <a:solidFill>
+              <a:srgbClr val="45556C"/>
+            </a:solidFill>
+            <a:prstDash val="solid"/>
+            <a:tailEnd type="arrow" w="med" len="med"/>
+          </a:ln>
+        </p:spPr>
+      </p:cxnSp>
+      <p:cxnSp>
+        <p:nvCxnSpPr>
+          <p:cNvPr id="111" name=""/>
+          <p:cNvCxnSpPr>
+            <a:stCxn xmlns:a="http://schemas.openxmlformats.org/drawingml/2006/main" id="57" idx="3"/>
+            <a:endCxn xmlns:a="http://schemas.openxmlformats.org/drawingml/2006/main" id="58" idx="1"/>
+          </p:cNvCxnSpPr>
+          <p:nvPr/>
+        </p:nvCxnSpPr>
+        <p:spPr>
+          <a:xfrm xmlns:a="http://schemas.openxmlformats.org/drawingml/2006/main">
+            <a:off x="3714750" y="2743200"/>
+            <a:ext cx="476250" cy="0"/>
+          </a:xfrm>
+          <a:prstGeom xmlns:a="http://schemas.openxmlformats.org/drawingml/2006/main" prst="straightConnector1">
             <a:avLst/>
           </a:prstGeom>
-        </p:spPr>
-      </p:pic>
+          <a:ln xmlns:a="http://schemas.openxmlformats.org/drawingml/2006/main" w="19050">
+            <a:solidFill>
+              <a:srgbClr val="45556C"/>
+            </a:solidFill>
+            <a:prstDash val="solid"/>
+            <a:tailEnd type="arrow" w="med" len="med"/>
+          </a:ln>
+        </p:spPr>
+      </p:cxnSp>
+      <p:cxnSp>
+        <p:nvCxnSpPr>
+          <p:cNvPr id="112" name=""/>
+          <p:cNvCxnSpPr>
+            <a:stCxn xmlns:a="http://schemas.openxmlformats.org/drawingml/2006/main" id="58" idx="3"/>
+            <a:endCxn xmlns:a="http://schemas.openxmlformats.org/drawingml/2006/main" id="59" idx="1"/>
+          </p:cNvCxnSpPr>
+          <p:nvPr/>
+        </p:nvCxnSpPr>
+        <p:spPr>
+          <a:xfrm xmlns:a="http://schemas.openxmlformats.org/drawingml/2006/main">
+            <a:off x="5476875" y="2743200"/>
+            <a:ext cx="476250" cy="0"/>
+          </a:xfrm>
+          <a:prstGeom xmlns:a="http://schemas.openxmlformats.org/drawingml/2006/main" prst="straightConnector1">
+            <a:avLst/>
+          </a:prstGeom>
+          <a:ln xmlns:a="http://schemas.openxmlformats.org/drawingml/2006/main" w="19050">
+            <a:solidFill>
+              <a:srgbClr val="45556C"/>
+            </a:solidFill>
+            <a:prstDash val="solid"/>
+            <a:tailEnd type="arrow" w="med" len="med"/>
+          </a:ln>
+        </p:spPr>
+      </p:cxnSp>
+      <p:cxnSp>
+        <p:nvCxnSpPr>
+          <p:cNvPr id="113" name=""/>
+          <p:cNvCxnSpPr>
+            <a:stCxn xmlns:a="http://schemas.openxmlformats.org/drawingml/2006/main" id="59" idx="3"/>
+            <a:endCxn xmlns:a="http://schemas.openxmlformats.org/drawingml/2006/main" id="62" idx="1"/>
+          </p:cNvCxnSpPr>
+          <p:nvPr/>
+        </p:nvCxnSpPr>
+        <p:spPr>
+          <a:xfrm xmlns:a="http://schemas.openxmlformats.org/drawingml/2006/main" flipV="1">
+            <a:off x="7524750" y="2505075"/>
+            <a:ext cx="1095375" cy="238125"/>
+          </a:xfrm>
+          <a:prstGeom xmlns:a="http://schemas.openxmlformats.org/drawingml/2006/main" prst="bentConnector3">
+            <a:avLst>
+              <a:gd name="adj1" fmla="val 50000"/>
+            </a:avLst>
+          </a:prstGeom>
+          <a:ln xmlns:a="http://schemas.openxmlformats.org/drawingml/2006/main" w="19050">
+            <a:solidFill>
+              <a:srgbClr val="45556C"/>
+            </a:solidFill>
+            <a:prstDash val="solid"/>
+            <a:tailEnd type="arrow" w="med" len="med"/>
+          </a:ln>
+        </p:spPr>
+      </p:cxnSp>
+      <p:cxnSp>
+        <p:nvCxnSpPr>
+          <p:cNvPr id="114" name=""/>
+          <p:cNvCxnSpPr>
+            <a:stCxn xmlns:a="http://schemas.openxmlformats.org/drawingml/2006/main" id="60" idx="3"/>
+            <a:endCxn xmlns:a="http://schemas.openxmlformats.org/drawingml/2006/main" id="61" idx="1"/>
+          </p:cNvCxnSpPr>
+          <p:nvPr/>
+        </p:nvCxnSpPr>
+        <p:spPr>
+          <a:xfrm xmlns:a="http://schemas.openxmlformats.org/drawingml/2006/main">
+            <a:off x="7762875" y="3971925"/>
+            <a:ext cx="381000" cy="133350"/>
+          </a:xfrm>
+          <a:prstGeom xmlns:a="http://schemas.openxmlformats.org/drawingml/2006/main" prst="bentConnector3">
+            <a:avLst>
+              <a:gd name="adj1" fmla="val 50000"/>
+            </a:avLst>
+          </a:prstGeom>
+          <a:ln xmlns:a="http://schemas.openxmlformats.org/drawingml/2006/main" w="19050">
+            <a:solidFill>
+              <a:srgbClr val="45556C"/>
+            </a:solidFill>
+            <a:prstDash val="solid"/>
+            <a:tailEnd type="arrow" w="med" len="med"/>
+          </a:ln>
+        </p:spPr>
+      </p:cxnSp>
+      <p:cxnSp>
+        <p:nvCxnSpPr>
+          <p:cNvPr id="115" name=""/>
+          <p:cNvCxnSpPr>
+            <a:stCxn xmlns:a="http://schemas.openxmlformats.org/drawingml/2006/main" id="61" idx="0"/>
+            <a:endCxn xmlns:a="http://schemas.openxmlformats.org/drawingml/2006/main" id="62" idx="2"/>
+          </p:cNvCxnSpPr>
+          <p:nvPr/>
+        </p:nvCxnSpPr>
+        <p:spPr>
+          <a:xfrm xmlns:a="http://schemas.openxmlformats.org/drawingml/2006/main" flipV="1">
+            <a:off x="9334500" y="2962275"/>
+            <a:ext cx="214313" cy="704850"/>
+          </a:xfrm>
+          <a:prstGeom xmlns:a="http://schemas.openxmlformats.org/drawingml/2006/main" prst="bentConnector4">
+            <a:avLst>
+              <a:gd name="adj1" fmla="val 0"/>
+              <a:gd name="adj2" fmla="val 50000"/>
+            </a:avLst>
+          </a:prstGeom>
+          <a:ln xmlns:a="http://schemas.openxmlformats.org/drawingml/2006/main" w="19050">
+            <a:solidFill>
+              <a:srgbClr val="45556C"/>
+            </a:solidFill>
+            <a:prstDash val="solid"/>
+            <a:tailEnd type="arrow" w="med" len="med"/>
+          </a:ln>
+        </p:spPr>
+      </p:cxnSp>
+      <p:cxnSp>
+        <p:nvCxnSpPr>
+          <p:cNvPr id="116" name=""/>
+          <p:cNvCxnSpPr>
+            <a:stCxn xmlns:a="http://schemas.openxmlformats.org/drawingml/2006/main" id="62" idx="3"/>
+            <a:endCxn xmlns:a="http://schemas.openxmlformats.org/drawingml/2006/main" id="63" idx="1"/>
+          </p:cNvCxnSpPr>
+          <p:nvPr/>
+        </p:nvCxnSpPr>
+        <p:spPr>
+          <a:xfrm xmlns:a="http://schemas.openxmlformats.org/drawingml/2006/main">
+            <a:off x="10477500" y="2505075"/>
+            <a:ext cx="333375" cy="104775"/>
+          </a:xfrm>
+          <a:prstGeom xmlns:a="http://schemas.openxmlformats.org/drawingml/2006/main" prst="bentConnector3">
+            <a:avLst>
+              <a:gd name="adj1" fmla="val 50000"/>
+            </a:avLst>
+          </a:prstGeom>
+          <a:ln xmlns:a="http://schemas.openxmlformats.org/drawingml/2006/main" w="19050">
+            <a:solidFill>
+              <a:srgbClr val="45556C"/>
+            </a:solidFill>
+            <a:prstDash val="solid"/>
+            <a:tailEnd type="arrow" w="med" len="med"/>
+          </a:ln>
+        </p:spPr>
+      </p:cxnSp>
+      <p:cxnSp>
+        <p:nvCxnSpPr>
+          <p:cNvPr id="117" name=""/>
+          <p:cNvCxnSpPr>
+            <a:stCxn xmlns:a="http://schemas.openxmlformats.org/drawingml/2006/main" id="63" idx="2"/>
+            <a:endCxn xmlns:a="http://schemas.openxmlformats.org/drawingml/2006/main" id="64" idx="0"/>
+          </p:cNvCxnSpPr>
+          <p:nvPr/>
+        </p:nvCxnSpPr>
+        <p:spPr>
+          <a:xfrm xmlns:a="http://schemas.openxmlformats.org/drawingml/2006/main">
+            <a:off x="11358563" y="2886075"/>
+            <a:ext cx="0" cy="447675"/>
+          </a:xfrm>
+          <a:prstGeom xmlns:a="http://schemas.openxmlformats.org/drawingml/2006/main" prst="straightConnector1">
+            <a:avLst/>
+          </a:prstGeom>
+          <a:ln xmlns:a="http://schemas.openxmlformats.org/drawingml/2006/main" w="19050">
+            <a:solidFill>
+              <a:srgbClr val="45556C"/>
+            </a:solidFill>
+            <a:prstDash val="solid"/>
+            <a:tailEnd type="arrow" w="med" len="med"/>
+          </a:ln>
+        </p:spPr>
+      </p:cxnSp>
+      <p:cxnSp>
+        <p:nvCxnSpPr>
+          <p:cNvPr id="118" name=""/>
+          <p:cNvCxnSpPr>
+            <a:stCxn xmlns:a="http://schemas.openxmlformats.org/drawingml/2006/main" id="64" idx="2"/>
+            <a:endCxn xmlns:a="http://schemas.openxmlformats.org/drawingml/2006/main" id="65" idx="0"/>
+          </p:cNvCxnSpPr>
+          <p:nvPr/>
+        </p:nvCxnSpPr>
+        <p:spPr>
+          <a:xfrm xmlns:a="http://schemas.openxmlformats.org/drawingml/2006/main" flipH="1">
+            <a:off x="11191875" y="3886200"/>
+            <a:ext cx="166688" cy="495300"/>
+          </a:xfrm>
+          <a:prstGeom xmlns:a="http://schemas.openxmlformats.org/drawingml/2006/main" prst="bentConnector4">
+            <a:avLst>
+              <a:gd name="adj1" fmla="val 0"/>
+              <a:gd name="adj2" fmla="val 50000"/>
+            </a:avLst>
+          </a:prstGeom>
+          <a:ln xmlns:a="http://schemas.openxmlformats.org/drawingml/2006/main" w="19050">
+            <a:solidFill>
+              <a:srgbClr val="45556C"/>
+            </a:solidFill>
+            <a:prstDash val="solid"/>
+            <a:tailEnd type="arrow" w="med" len="med"/>
+          </a:ln>
+        </p:spPr>
+      </p:cxnSp>
     </p:spTree>
     <p:extLst>
       <p:ext uri="{BB962C8B-B14F-4D97-AF65-F5344CB8AC3E}">

</xml_diff>

<commit_message>
docs: use p cancer consistently in model slide
</commit_message>
<xml_diff>
--- a/docs/presentation/Aramina_Product_Overview_2026-07-27.pptx
+++ b/docs/presentation/Aramina_Product_Overview_2026-07-27.pptx
@@ -2,19 +2,19 @@
 <file path=ppt/presentation.xml><?xml version="1.0" encoding="utf-8"?>
 <p:presentation xmlns:p="http://schemas.openxmlformats.org/presentationml/2006/main">
   <p:sldMasterIdLst>
-    <p:sldMasterId xmlns:r="http://schemas.openxmlformats.org/officeDocument/2006/relationships" id="2147483648" r:id="R9acf0f6d2fb34872"/>
+    <p:sldMasterId xmlns:r="http://schemas.openxmlformats.org/officeDocument/2006/relationships" id="2147483648" r:id="R6c865c21c9c04cd2"/>
   </p:sldMasterIdLst>
   <p:notesMasterIdLst>
-    <p:notesMasterId xmlns:r="http://schemas.openxmlformats.org/officeDocument/2006/relationships" r:id="R94908dee10fc4145"/>
+    <p:notesMasterId xmlns:r="http://schemas.openxmlformats.org/officeDocument/2006/relationships" r:id="R00903b0d2be041ab"/>
   </p:notesMasterIdLst>
   <p:sldIdLst>
-    <p:sldId xmlns:r="http://schemas.openxmlformats.org/officeDocument/2006/relationships" id="256" r:id="Rd64f462315904c1c"/>
-    <p:sldId xmlns:r="http://schemas.openxmlformats.org/officeDocument/2006/relationships" id="257" r:id="R44723b5f579d4c42"/>
-    <p:sldId xmlns:r="http://schemas.openxmlformats.org/officeDocument/2006/relationships" id="258" r:id="R3fc5912a138c4dae"/>
-    <p:sldId xmlns:r="http://schemas.openxmlformats.org/officeDocument/2006/relationships" id="259" r:id="Raaae27333402417c"/>
-    <p:sldId xmlns:r="http://schemas.openxmlformats.org/officeDocument/2006/relationships" id="260" r:id="Rce9b4d4ccab149dd"/>
-    <p:sldId xmlns:r="http://schemas.openxmlformats.org/officeDocument/2006/relationships" id="261" r:id="Rc886273227154d88"/>
-    <p:sldId xmlns:r="http://schemas.openxmlformats.org/officeDocument/2006/relationships" id="262" r:id="Rdf1916c70c7b4a12"/>
+    <p:sldId xmlns:r="http://schemas.openxmlformats.org/officeDocument/2006/relationships" id="256" r:id="R02a9475dce27403d"/>
+    <p:sldId xmlns:r="http://schemas.openxmlformats.org/officeDocument/2006/relationships" id="257" r:id="R8633664a3cf14869"/>
+    <p:sldId xmlns:r="http://schemas.openxmlformats.org/officeDocument/2006/relationships" id="258" r:id="R5da04b54236b42bf"/>
+    <p:sldId xmlns:r="http://schemas.openxmlformats.org/officeDocument/2006/relationships" id="259" r:id="R11a66998cd1c44a6"/>
+    <p:sldId xmlns:r="http://schemas.openxmlformats.org/officeDocument/2006/relationships" id="260" r:id="R67080e1efe1b4f7e"/>
+    <p:sldId xmlns:r="http://schemas.openxmlformats.org/officeDocument/2006/relationships" id="261" r:id="Rd6f23d72c2bd41da"/>
+    <p:sldId xmlns:r="http://schemas.openxmlformats.org/officeDocument/2006/relationships" id="262" r:id="Raa99179f4fb54442"/>
   </p:sldIdLst>
   <p:sldSz cx="12192000" cy="6858000"/>
   <p:notesSz cx="6858000" cy="9144000"/>
@@ -1171,8 +1171,8 @@
   </p:cSld>
   <p:clrMap bg1="lt1" tx1="dk1" bg2="lt2" tx2="dk2" accent1="accent1" accent2="accent2" accent3="accent3" accent4="accent4" accent5="accent5" accent6="accent6" hlink="hlink" folHlink="folHlink"/>
   <p:sldLayoutIdLst>
-    <p:sldLayoutId xmlns:r="http://schemas.openxmlformats.org/officeDocument/2006/relationships" id="2147483649" r:id="Rd7eaa4f918f444a2"/>
-    <p:sldLayoutId xmlns:r="http://schemas.openxmlformats.org/officeDocument/2006/relationships" id="2147483650" r:id="R204eeeceb5814668"/>
+    <p:sldLayoutId xmlns:r="http://schemas.openxmlformats.org/officeDocument/2006/relationships" id="2147483649" r:id="Re01b4d5626c3475b"/>
+    <p:sldLayoutId xmlns:r="http://schemas.openxmlformats.org/officeDocument/2006/relationships" id="2147483650" r:id="R928b7ae28a564ca2"/>
   </p:sldLayoutIdLst>
   <p:txStyles>
     <p:titleStyle>
@@ -3620,7 +3620,7 @@
           <p:nvPr/>
         </p:nvPicPr>
         <p:blipFill>
-          <a:blip xmlns:r="http://schemas.openxmlformats.org/officeDocument/2006/relationships" xmlns:a="http://schemas.openxmlformats.org/drawingml/2006/main" r:embed="R7e7ea9f714e84a81"/>
+          <a:blip xmlns:r="http://schemas.openxmlformats.org/officeDocument/2006/relationships" xmlns:a="http://schemas.openxmlformats.org/drawingml/2006/main" r:embed="R39f4d2a51cde4e61"/>
           <a:stretch xmlns:a="http://schemas.openxmlformats.org/drawingml/2006/main"/>
         </p:blipFill>
         <p:spPr>
@@ -5791,7 +5791,7 @@
           <p:cNvPr id="54" name="P1 profile">
             <a:extLst xmlns:a="http://schemas.openxmlformats.org/drawingml/2006/main">
               <a:ext uri="{FF2B5EF4-FFF2-40B4-BE49-F238E27FC236}">
-                <a16:creationId xmlns:a16="http://schemas.microsoft.com/office/drawing/2014/main" id="{53124C45-4284-4398-B5D4-56C6F93234BE}"/>
+                <a16:creationId xmlns:a16="http://schemas.microsoft.com/office/drawing/2014/main" id="{2BF67D02-1C81-472F-B189-A92F270DF0E0}"/>
               </a:ext>
             </a:extLst>
           </p:cNvPr>
@@ -5864,7 +5864,7 @@
           <p:cNvPr id="55" name="P2 profile">
             <a:extLst xmlns:a="http://schemas.openxmlformats.org/drawingml/2006/main">
               <a:ext uri="{FF2B5EF4-FFF2-40B4-BE49-F238E27FC236}">
-                <a16:creationId xmlns:a16="http://schemas.microsoft.com/office/drawing/2014/main" id="{D6CFBB4D-0601-439B-9DCD-1E58D6902208}"/>
+                <a16:creationId xmlns:a16="http://schemas.microsoft.com/office/drawing/2014/main" id="{37CB53B8-4FE8-4EE1-B9B8-7F6F1C7954B7}"/>
               </a:ext>
             </a:extLst>
           </p:cNvPr>
@@ -5937,7 +5937,7 @@
           <p:cNvPr id="56" name="P3 profile">
             <a:extLst xmlns:a="http://schemas.openxmlformats.org/drawingml/2006/main">
               <a:ext uri="{FF2B5EF4-FFF2-40B4-BE49-F238E27FC236}">
-                <a16:creationId xmlns:a16="http://schemas.microsoft.com/office/drawing/2014/main" id="{F3DEA6A2-0D8C-484C-A588-1BC66A30B5DA}"/>
+                <a16:creationId xmlns:a16="http://schemas.microsoft.com/office/drawing/2014/main" id="{46F074E5-EFC3-4974-B768-B4E092174CAF}"/>
               </a:ext>
             </a:extLst>
           </p:cNvPr>
@@ -6010,7 +6010,7 @@
           <p:cNvPr id="57" name="LR1 profile model">
             <a:extLst xmlns:a="http://schemas.openxmlformats.org/drawingml/2006/main">
               <a:ext uri="{FF2B5EF4-FFF2-40B4-BE49-F238E27FC236}">
-                <a16:creationId xmlns:a16="http://schemas.microsoft.com/office/drawing/2014/main" id="{FC6087C2-AF07-4211-A4C2-D1BEE86AAC4C}"/>
+                <a16:creationId xmlns:a16="http://schemas.microsoft.com/office/drawing/2014/main" id="{C651EF92-0EF3-4FBD-B6D4-FF9287A8AF1F}"/>
               </a:ext>
             </a:extLst>
           </p:cNvPr>
@@ -6083,7 +6083,7 @@
           <p:cNvPr id="58" name="Measurement p target">
             <a:extLst xmlns:a="http://schemas.openxmlformats.org/drawingml/2006/main">
               <a:ext uri="{FF2B5EF4-FFF2-40B4-BE49-F238E27FC236}">
-                <a16:creationId xmlns:a16="http://schemas.microsoft.com/office/drawing/2014/main" id="{F9C68B05-F0CE-49AC-95DF-C344C4DFC38C}"/>
+                <a16:creationId xmlns:a16="http://schemas.microsoft.com/office/drawing/2014/main" id="{96713C7A-42AB-4E88-B683-992551198A0C}"/>
               </a:ext>
             </a:extLst>
           </p:cNvPr>
@@ -6129,7 +6129,7 @@
                   <a:srgbClr val="000000"/>
                 </a:solidFill>
               </a:rPr>
-              <a:t>p_target 1</a:t>
+              <a:t>p_cancer 1</a:t>
             </a:r>
           </a:p>
           <a:p xmlns:a="http://schemas.openxmlformats.org/drawingml/2006/main">
@@ -6146,7 +6146,7 @@
                   <a:srgbClr val="000000"/>
                 </a:solidFill>
               </a:rPr>
-              <a:t>p_target 2</a:t>
+              <a:t>p_cancer 2</a:t>
             </a:r>
           </a:p>
           <a:p xmlns:a="http://schemas.openxmlformats.org/drawingml/2006/main">
@@ -6163,7 +6163,7 @@
                   <a:srgbClr val="000000"/>
                 </a:solidFill>
               </a:rPr>
-              <a:t>p_target 3</a:t>
+              <a:t>p_cancer 3</a:t>
             </a:r>
           </a:p>
         </p:txBody>
@@ -6173,7 +6173,7 @@
           <p:cNvPr id="59" name="Target p target aggregate">
             <a:extLst xmlns:a="http://schemas.openxmlformats.org/drawingml/2006/main">
               <a:ext uri="{FF2B5EF4-FFF2-40B4-BE49-F238E27FC236}">
-                <a16:creationId xmlns:a16="http://schemas.microsoft.com/office/drawing/2014/main" id="{294954D9-5CDC-4D55-8773-8AF5CC75A577}"/>
+                <a16:creationId xmlns:a16="http://schemas.microsoft.com/office/drawing/2014/main" id="{640F9F9B-0A78-4331-8DE1-44B2550AF197}"/>
               </a:ext>
             </a:extLst>
           </p:cNvPr>
@@ -6219,7 +6219,7 @@
                   <a:srgbClr val="000000"/>
                 </a:solidFill>
               </a:rPr>
-              <a:t>target p_target</a:t>
+              <a:t>target p_cancer</a:t>
             </a:r>
           </a:p>
           <a:p xmlns:a="http://schemas.openxmlformats.org/drawingml/2006/main">
@@ -6246,7 +6246,7 @@
           <p:cNvPr id="60" name="Symmetry availability gate">
             <a:extLst xmlns:a="http://schemas.openxmlformats.org/drawingml/2006/main">
               <a:ext uri="{FF2B5EF4-FFF2-40B4-BE49-F238E27FC236}">
-                <a16:creationId xmlns:a16="http://schemas.microsoft.com/office/drawing/2014/main" id="{89E36C25-83C7-42BE-9E41-395FDCC8D2EC}"/>
+                <a16:creationId xmlns:a16="http://schemas.microsoft.com/office/drawing/2014/main" id="{FD1B05F1-DDC7-4F23-B090-28236A7E181D}"/>
               </a:ext>
             </a:extLst>
           </p:cNvPr>
@@ -6319,7 +6319,7 @@
           <p:cNvPr id="61" name="Symmetry input to LR2">
             <a:extLst xmlns:a="http://schemas.openxmlformats.org/drawingml/2006/main">
               <a:ext uri="{FF2B5EF4-FFF2-40B4-BE49-F238E27FC236}">
-                <a16:creationId xmlns:a16="http://schemas.microsoft.com/office/drawing/2014/main" id="{9191F082-3FD3-4904-9D48-A4B063A7AFE3}"/>
+                <a16:creationId xmlns:a16="http://schemas.microsoft.com/office/drawing/2014/main" id="{11B442EE-063B-4A5D-8581-689CEF5A50A1}"/>
               </a:ext>
             </a:extLst>
           </p:cNvPr>
@@ -6409,7 +6409,7 @@
           <p:cNvPr id="62" name="LR2 refinement">
             <a:extLst xmlns:a="http://schemas.openxmlformats.org/drawingml/2006/main">
               <a:ext uri="{FF2B5EF4-FFF2-40B4-BE49-F238E27FC236}">
-                <a16:creationId xmlns:a16="http://schemas.microsoft.com/office/drawing/2014/main" id="{D1D46F84-59A7-4B6C-9F1B-A21BE87430EB}"/>
+                <a16:creationId xmlns:a16="http://schemas.microsoft.com/office/drawing/2014/main" id="{8E0B521B-23F0-4F42-B33F-6CC576B4ED7C}"/>
               </a:ext>
             </a:extLst>
           </p:cNvPr>
@@ -6472,7 +6472,7 @@
                   <a:srgbClr val="000000"/>
                 </a:solidFill>
               </a:rPr>
-              <a:t>target p_target + age</a:t>
+              <a:t>target p_cancer + age</a:t>
             </a:r>
           </a:p>
           <a:p xmlns:a="http://schemas.openxmlformats.org/drawingml/2006/main">
@@ -6499,7 +6499,7 @@
           <p:cNvPr id="63" name="Final p cancer">
             <a:extLst xmlns:a="http://schemas.openxmlformats.org/drawingml/2006/main">
               <a:ext uri="{FF2B5EF4-FFF2-40B4-BE49-F238E27FC236}">
-                <a16:creationId xmlns:a16="http://schemas.microsoft.com/office/drawing/2014/main" id="{1CCFD13E-1E77-463B-92F6-FA2072DD3326}"/>
+                <a16:creationId xmlns:a16="http://schemas.microsoft.com/office/drawing/2014/main" id="{1F096C3A-794D-4232-8DD2-2A9472B619FB}"/>
               </a:ext>
             </a:extLst>
           </p:cNvPr>
@@ -6555,7 +6555,7 @@
           <p:cNvPr id="64" name="Fixed threshold">
             <a:extLst xmlns:a="http://schemas.openxmlformats.org/drawingml/2006/main">
               <a:ext uri="{FF2B5EF4-FFF2-40B4-BE49-F238E27FC236}">
-                <a16:creationId xmlns:a16="http://schemas.microsoft.com/office/drawing/2014/main" id="{D6B1C326-BC04-462C-B005-FF8A61C8FA45}"/>
+                <a16:creationId xmlns:a16="http://schemas.microsoft.com/office/drawing/2014/main" id="{0CDC433A-E8D8-45F4-BEDC-50D63393072C}"/>
               </a:ext>
             </a:extLst>
           </p:cNvPr>
@@ -6628,7 +6628,7 @@
           <p:cNvPr id="65" name="Biopsy action">
             <a:extLst xmlns:a="http://schemas.openxmlformats.org/drawingml/2006/main">
               <a:ext uri="{FF2B5EF4-FFF2-40B4-BE49-F238E27FC236}">
-                <a16:creationId xmlns:a16="http://schemas.microsoft.com/office/drawing/2014/main" id="{1DBCDF89-7735-4560-9624-CA79194C0D3E}"/>
+                <a16:creationId xmlns:a16="http://schemas.microsoft.com/office/drawing/2014/main" id="{DDE74153-6BDC-4CB5-993D-4FDCAC846DD7}"/>
               </a:ext>
             </a:extLst>
           </p:cNvPr>

</xml_diff>